<commit_message>
Add accessible PPT PDFs and update lectures
Add accessible PDF exports for CSC 621 Research Methods (Chapters 9–12) and update the corresponding PPTX files. Also refresh IT 647 Data Mining lecture PDFs (Lecture 9 and Lecture 10). These changes provide accessible presentation PDFs and updated lecture materials.
</commit_message>
<xml_diff>
--- a/Chapter Two 1447/CSC 621 Research Methods/Lectures/Ch-09-PPTaccessible.pptx
+++ b/Chapter Two 1447/CSC 621 Research Methods/Lectures/Ch-09-PPTaccessible.pptx
@@ -2,29 +2,29 @@
 <file path=ppt/presentation.xml><?xml version="1.0" encoding="utf-8"?>
 <p:presentation xmlns:a="http://schemas.openxmlformats.org/drawingml/2006/main" xmlns:r="http://schemas.openxmlformats.org/officeDocument/2006/relationships" xmlns:p="http://schemas.openxmlformats.org/presentationml/2006/main" strictFirstAndLastChars="0" saveSubsetFonts="1" autoCompressPictures="0">
   <p:sldMasterIdLst>
-    <p:sldMasterId id="2147483659" r:id="rId1"/>
-    <p:sldMasterId id="2147483660" r:id="rId2"/>
+    <p:sldMasterId id="2147483659" r:id="rId4"/>
+    <p:sldMasterId id="2147483660" r:id="rId5"/>
   </p:sldMasterIdLst>
   <p:notesMasterIdLst>
-    <p:notesMasterId r:id="rId16"/>
+    <p:notesMasterId r:id="rId19"/>
   </p:notesMasterIdLst>
   <p:handoutMasterIdLst>
-    <p:handoutMasterId r:id="rId17"/>
+    <p:handoutMasterId r:id="rId20"/>
   </p:handoutMasterIdLst>
   <p:sldIdLst>
-    <p:sldId id="335" r:id="rId3"/>
-    <p:sldId id="307" r:id="rId4"/>
-    <p:sldId id="308" r:id="rId5"/>
-    <p:sldId id="342" r:id="rId6"/>
-    <p:sldId id="310" r:id="rId7"/>
-    <p:sldId id="311" r:id="rId8"/>
-    <p:sldId id="338" r:id="rId9"/>
-    <p:sldId id="339" r:id="rId10"/>
-    <p:sldId id="340" r:id="rId11"/>
-    <p:sldId id="312" r:id="rId12"/>
-    <p:sldId id="341" r:id="rId13"/>
-    <p:sldId id="313" r:id="rId14"/>
-    <p:sldId id="334" r:id="rId15"/>
+    <p:sldId id="335" r:id="rId6"/>
+    <p:sldId id="307" r:id="rId7"/>
+    <p:sldId id="308" r:id="rId8"/>
+    <p:sldId id="342" r:id="rId9"/>
+    <p:sldId id="310" r:id="rId10"/>
+    <p:sldId id="311" r:id="rId11"/>
+    <p:sldId id="338" r:id="rId12"/>
+    <p:sldId id="339" r:id="rId13"/>
+    <p:sldId id="340" r:id="rId14"/>
+    <p:sldId id="312" r:id="rId15"/>
+    <p:sldId id="341" r:id="rId16"/>
+    <p:sldId id="313" r:id="rId17"/>
+    <p:sldId id="334" r:id="rId18"/>
   </p:sldIdLst>
   <p:sldSz cx="9144000" cy="6858000" type="screen4x3"/>
   <p:notesSz cx="6858000" cy="9144000"/>
@@ -367,7 +367,7 @@
           <a:p>
             <a:fld id="{2885CB01-6679-D646-ACB3-8B04B786C15F}" type="datetimeFigureOut">
               <a:rPr lang="en-US" smtClean="0"/>
-              <a:t>10/20/2021</a:t>
+              <a:t>5/31/2026</a:t>
             </a:fld>
             <a:endParaRPr lang="en-US"/>
           </a:p>
@@ -16255,8 +16255,8 @@
         </p:nvSpPr>
         <p:spPr>
           <a:xfrm>
-            <a:off x="457200" y="303062"/>
-            <a:ext cx="8229600" cy="1144347"/>
+            <a:off x="457200" y="980170"/>
+            <a:ext cx="8229600" cy="467239"/>
           </a:xfrm>
         </p:spPr>
         <p:txBody>
@@ -16272,13 +16272,13 @@
               <a:buClrTx/>
             </a:pPr>
             <a:r>
-              <a:rPr lang="en-US" altLang="en-US" sz="3600" kern="1200" dirty="0">
+              <a:rPr lang="en-US" altLang="en-US" sz="2800" kern="1200" dirty="0">
                 <a:latin typeface="+mj-lt"/>
                 <a:cs typeface="Times New Roman" panose="02020603050405020304" pitchFamily="18" charset="0"/>
               </a:rPr>
               <a:t>Analyzing and Interpreting Mixed-Methods Data</a:t>
             </a:r>
-            <a:endParaRPr lang="en-US" sz="2800" kern="1200" dirty="0">
+            <a:endParaRPr lang="en-US" sz="2000" kern="1200" dirty="0">
               <a:latin typeface="+mj-lt"/>
               <a:ea typeface="+mj-ea"/>
               <a:cs typeface="Times New Roman" panose="02020603050405020304" pitchFamily="18" charset="0"/>
@@ -19457,6 +19457,21 @@
 </file>
 
 <file path=customXml/item1.xml><?xml version="1.0" encoding="utf-8"?>
+<p:properties xmlns:p="http://schemas.microsoft.com/office/2006/metadata/properties" xmlns:xsi="http://www.w3.org/2001/XMLSchema-instance" xmlns:pc="http://schemas.microsoft.com/office/infopath/2007/PartnerControls">
+  <documentManagement/>
+</p:properties>
+</file>
+
+<file path=customXml/item2.xml><?xml version="1.0" encoding="utf-8"?>
+<?mso-contentType ?>
+<FormTemplates xmlns="http://schemas.microsoft.com/sharepoint/v3/contenttype/forms">
+  <Display>DocumentLibraryForm</Display>
+  <Edit>DocumentLibraryForm</Edit>
+  <New>DocumentLibraryForm</New>
+</FormTemplates>
+</file>
+
+<file path=customXml/item3.xml><?xml version="1.0" encoding="utf-8"?>
 <ct:contentTypeSchema xmlns:ct="http://schemas.microsoft.com/office/2006/metadata/contentType" xmlns:ma="http://schemas.microsoft.com/office/2006/metadata/properties/metaAttributes" ct:_="" ma:_="" ma:contentTypeName="Document" ma:contentTypeID="0x01010086D90B95B22DD945BDFF45EB84A5E21C" ma:contentTypeVersion="12" ma:contentTypeDescription="Create a new document." ma:contentTypeScope="" ma:versionID="9ee3781bcb6633d132c89161492bb118">
   <xsd:schema xmlns:xsd="http://www.w3.org/2001/XMLSchema" xmlns:xs="http://www.w3.org/2001/XMLSchema" xmlns:p="http://schemas.microsoft.com/office/2006/metadata/properties" xmlns:ns2="7c1bd8dc-4e40-424f-a15f-9ffcd522197f" xmlns:ns3="6125ffc9-2c56-435e-8267-1393444907b2" targetNamespace="http://schemas.microsoft.com/office/2006/metadata/properties" ma:root="true" ma:fieldsID="d3e430f46b92204fb5a3381a429c4dbe" ns2:_="" ns3:_="">
     <xsd:import namespace="7c1bd8dc-4e40-424f-a15f-9ffcd522197f"/>
@@ -19673,29 +19688,38 @@
 </ct:contentTypeSchema>
 </file>
 
-<file path=customXml/item2.xml><?xml version="1.0" encoding="utf-8"?>
-<?mso-contentType ?>
-<FormTemplates xmlns="http://schemas.microsoft.com/sharepoint/v3/contenttype/forms">
-  <Display>DocumentLibraryForm</Display>
-  <Edit>DocumentLibraryForm</Edit>
-  <New>DocumentLibraryForm</New>
-</FormTemplates>
-</file>
-
-<file path=customXml/item3.xml><?xml version="1.0" encoding="utf-8"?>
-<p:properties xmlns:p="http://schemas.microsoft.com/office/2006/metadata/properties" xmlns:xsi="http://www.w3.org/2001/XMLSchema-instance" xmlns:pc="http://schemas.microsoft.com/office/infopath/2007/PartnerControls">
-  <documentManagement/>
-</p:properties>
-</file>
-
 <file path=customXml/itemProps1.xml><?xml version="1.0" encoding="utf-8"?>
-<ds:datastoreItem xmlns:ds="http://schemas.openxmlformats.org/officeDocument/2006/customXml" ds:itemID="{C944D3BB-5530-45F5-8009-24BE1EAE62CD}"/>
+<ds:datastoreItem xmlns:ds="http://schemas.openxmlformats.org/officeDocument/2006/customXml" ds:itemID="{5448D24B-9F40-4BC9-9E82-8D7BA94627C1}">
+  <ds:schemaRefs>
+    <ds:schemaRef ds:uri="http://schemas.microsoft.com/office/2006/metadata/properties"/>
+    <ds:schemaRef ds:uri="http://schemas.microsoft.com/office/infopath/2007/PartnerControls"/>
+  </ds:schemaRefs>
+</ds:datastoreItem>
 </file>
 
 <file path=customXml/itemProps2.xml><?xml version="1.0" encoding="utf-8"?>
-<ds:datastoreItem xmlns:ds="http://schemas.openxmlformats.org/officeDocument/2006/customXml" ds:itemID="{EB3974BE-3157-4651-8BC6-D915B962EFEF}"/>
+<ds:datastoreItem xmlns:ds="http://schemas.openxmlformats.org/officeDocument/2006/customXml" ds:itemID="{EB3974BE-3157-4651-8BC6-D915B962EFEF}">
+  <ds:schemaRefs>
+    <ds:schemaRef ds:uri="http://schemas.microsoft.com/sharepoint/v3/contenttype/forms"/>
+  </ds:schemaRefs>
+</ds:datastoreItem>
 </file>
 
 <file path=customXml/itemProps3.xml><?xml version="1.0" encoding="utf-8"?>
-<ds:datastoreItem xmlns:ds="http://schemas.openxmlformats.org/officeDocument/2006/customXml" ds:itemID="{5448D24B-9F40-4BC9-9E82-8D7BA94627C1}"/>
+<ds:datastoreItem xmlns:ds="http://schemas.openxmlformats.org/officeDocument/2006/customXml" ds:itemID="{C944D3BB-5530-45F5-8009-24BE1EAE62CD}">
+  <ds:schemaRefs>
+    <ds:schemaRef ds:uri="http://schemas.microsoft.com/office/2006/metadata/contentType"/>
+    <ds:schemaRef ds:uri="http://schemas.microsoft.com/office/2006/metadata/properties/metaAttributes"/>
+    <ds:schemaRef ds:uri="http://www.w3.org/2001/XMLSchema"/>
+    <ds:schemaRef ds:uri="http://schemas.microsoft.com/office/2006/metadata/properties"/>
+    <ds:schemaRef ds:uri="7c1bd8dc-4e40-424f-a15f-9ffcd522197f"/>
+    <ds:schemaRef ds:uri="6125ffc9-2c56-435e-8267-1393444907b2"/>
+    <ds:schemaRef ds:uri="http://schemas.microsoft.com/office/2006/documentManagement/types"/>
+    <ds:schemaRef ds:uri="http://schemas.microsoft.com/office/infopath/2007/PartnerControls"/>
+    <ds:schemaRef ds:uri="http://schemas.openxmlformats.org/package/2006/metadata/core-properties"/>
+    <ds:schemaRef ds:uri="http://purl.org/dc/elements/1.1/"/>
+    <ds:schemaRef ds:uri="http://purl.org/dc/terms/"/>
+    <ds:schemaRef ds:uri="http://schemas.microsoft.com/internal/obd"/>
+  </ds:schemaRefs>
+</ds:datastoreItem>
 </file>
</xml_diff>